<commit_message>
docs: update project documentation and tasks
</commit_message>
<xml_diff>
--- a/docs/academico/IES Abastos. 2025-26. Presentacion IA & Big Data. 8IA. Daniel.pptx
+++ b/docs/academico/IES Abastos. 2025-26. Presentacion IA & Big Data. 8IA. Daniel.pptx
@@ -15655,7 +15655,7 @@
         <p:spPr>
           <a:xfrm>
             <a:off x="571500" y="1333500"/>
-            <a:ext cx="11049000" cy="4953000"/>
+            <a:ext cx="11049000" cy="4857600"/>
           </a:xfrm>
           <a:prstGeom prst="roundRect">
             <a:avLst>
@@ -18310,6 +18310,18 @@
                 <a:buNone/>
               </a:pPr>
               <a:r>
+                <a:rPr lang="en-US">
+                  <a:solidFill>
+                    <a:srgbClr val="DAFFDE"/>
+                  </a:solidFill>
+                  <a:latin typeface="Inter"/>
+                  <a:ea typeface="Inter"/>
+                  <a:cs typeface="Inter"/>
+                  <a:sym typeface="Inter"/>
+                </a:rPr>
+                <a:t>4300</a:t>
+              </a:r>
+              <a:r>
                 <a:rPr b="0" lang="en-US" sz="1400">
                   <a:solidFill>
                     <a:srgbClr val="DAFFDE"/>
@@ -18319,7 +18331,7 @@
                   <a:cs typeface="Inter"/>
                   <a:sym typeface="Inter"/>
                 </a:rPr>
-                <a:t>5.000+ productos diarios analizados. La detección manual de cambios es técnicamente inviable.</a:t>
+                <a:t>+ productos diarios analizados. La detección manual de cambios es técnicamente inviable.</a:t>
               </a:r>
               <a:endParaRPr b="0" sz="1400">
                 <a:solidFill>
@@ -20069,15 +20081,116 @@
           </a:p>
         </p:txBody>
       </p:sp>
+      <p:sp>
+        <p:nvSpPr>
+          <p:cNvPr id="144" name="Google Shape;144;p17"/>
+          <p:cNvSpPr txBox="1"/>
+          <p:nvPr/>
+        </p:nvSpPr>
+        <p:spPr>
+          <a:xfrm>
+            <a:off x="809625" y="571500"/>
+            <a:ext cx="11351400" cy="554100"/>
+          </a:xfrm>
+          <a:prstGeom prst="rect">
+            <a:avLst/>
+          </a:prstGeom>
+          <a:noFill/>
+          <a:ln>
+            <a:noFill/>
+          </a:ln>
+        </p:spPr>
+        <p:txBody>
+          <a:bodyPr anchorCtr="0" anchor="t" bIns="0" lIns="0" spcFirstLastPara="1" rIns="0" wrap="square" tIns="0">
+            <a:spAutoFit/>
+          </a:bodyPr>
+          <a:lstStyle/>
+          <a:p>
+            <a:pPr indent="0" lvl="0" marL="0" marR="0" rtl="0" algn="l">
+              <a:spcBef>
+                <a:spcPts val="0"/>
+              </a:spcBef>
+              <a:spcAft>
+                <a:spcPts val="0"/>
+              </a:spcAft>
+              <a:buNone/>
+            </a:pPr>
+            <a:r>
+              <a:rPr b="1" i="0" lang="en-US" sz="3600" u="none" cap="none" strike="noStrike">
+                <a:solidFill>
+                  <a:srgbClr val="F5F5F5"/>
+                </a:solidFill>
+                <a:latin typeface="Urbanist"/>
+                <a:ea typeface="Urbanist"/>
+                <a:cs typeface="Urbanist"/>
+                <a:sym typeface="Urbanist"/>
+              </a:rPr>
+              <a:t>El dataset: 176 días de inteligencia</a:t>
+            </a:r>
+            <a:endParaRPr/>
+          </a:p>
+        </p:txBody>
+      </p:sp>
+      <p:sp>
+        <p:nvSpPr>
+          <p:cNvPr id="145" name="Google Shape;145;p17"/>
+          <p:cNvSpPr/>
+          <p:nvPr/>
+        </p:nvSpPr>
+        <p:spPr>
+          <a:xfrm>
+            <a:off x="571500" y="571500"/>
+            <a:ext cx="57300" cy="552600"/>
+          </a:xfrm>
+          <a:prstGeom prst="rect">
+            <a:avLst/>
+          </a:prstGeom>
+          <a:solidFill>
+            <a:srgbClr val="00C853"/>
+          </a:solidFill>
+          <a:ln>
+            <a:noFill/>
+          </a:ln>
+        </p:spPr>
+        <p:txBody>
+          <a:bodyPr anchorCtr="0" anchor="ctr" bIns="45700" lIns="91425" spcFirstLastPara="1" rIns="91425" wrap="square" tIns="45700">
+            <a:noAutofit/>
+          </a:bodyPr>
+          <a:lstStyle/>
+          <a:p>
+            <a:pPr indent="0" lvl="0" marL="0" marR="0" rtl="0" algn="ctr">
+              <a:spcBef>
+                <a:spcPts val="0"/>
+              </a:spcBef>
+              <a:spcAft>
+                <a:spcPts val="0"/>
+              </a:spcAft>
+              <a:buNone/>
+            </a:pPr>
+            <a:r>
+              <a:t/>
+            </a:r>
+            <a:endParaRPr b="0" i="0" sz="1800" u="none" cap="none" strike="noStrike">
+              <a:solidFill>
+                <a:schemeClr val="dk1"/>
+              </a:solidFill>
+              <a:latin typeface="Calibri"/>
+              <a:ea typeface="Calibri"/>
+              <a:cs typeface="Calibri"/>
+              <a:sym typeface="Calibri"/>
+            </a:endParaRPr>
+          </a:p>
+        </p:txBody>
+      </p:sp>
       <p:grpSp>
         <p:nvGrpSpPr>
-          <p:cNvPr id="144" name="Google Shape;144;p17"/>
+          <p:cNvPr id="146" name="Google Shape;146;p17"/>
           <p:cNvGrpSpPr/>
           <p:nvPr/>
         </p:nvGrpSpPr>
         <p:grpSpPr>
           <a:xfrm>
-            <a:off x="571500" y="1524000"/>
+            <a:off x="571500" y="1811461"/>
             <a:ext cx="11096625" cy="3238500"/>
             <a:chOff x="571500" y="1524000"/>
             <a:chExt cx="11096625" cy="3238500"/>
@@ -20085,7 +20198,7 @@
         </p:grpSpPr>
         <p:sp>
           <p:nvSpPr>
-            <p:cNvPr id="145" name="Google Shape;145;p17"/>
+            <p:cNvPr id="147" name="Google Shape;147;p17"/>
             <p:cNvSpPr/>
             <p:nvPr/>
           </p:nvSpPr>
@@ -20136,7 +20249,7 @@
         </p:sp>
         <p:sp>
           <p:nvSpPr>
-            <p:cNvPr id="146" name="Google Shape;146;p17"/>
+            <p:cNvPr id="148" name="Google Shape;148;p17"/>
             <p:cNvSpPr txBox="1"/>
             <p:nvPr/>
           </p:nvSpPr>
@@ -20258,7 +20371,7 @@
         </p:sp>
         <p:sp>
           <p:nvSpPr>
-            <p:cNvPr id="147" name="Google Shape;147;p17"/>
+            <p:cNvPr id="149" name="Google Shape;149;p17"/>
             <p:cNvSpPr/>
             <p:nvPr/>
           </p:nvSpPr>
@@ -20309,7 +20422,7 @@
         </p:sp>
         <p:sp>
           <p:nvSpPr>
-            <p:cNvPr id="148" name="Google Shape;148;p17"/>
+            <p:cNvPr id="150" name="Google Shape;150;p17"/>
             <p:cNvSpPr txBox="1"/>
             <p:nvPr/>
           </p:nvSpPr>
@@ -20431,7 +20544,7 @@
         </p:sp>
         <p:sp>
           <p:nvSpPr>
-            <p:cNvPr id="149" name="Google Shape;149;p17"/>
+            <p:cNvPr id="151" name="Google Shape;151;p17"/>
             <p:cNvSpPr/>
             <p:nvPr/>
           </p:nvSpPr>
@@ -20482,7 +20595,7 @@
         </p:sp>
         <p:sp>
           <p:nvSpPr>
-            <p:cNvPr id="150" name="Google Shape;150;p17"/>
+            <p:cNvPr id="152" name="Google Shape;152;p17"/>
             <p:cNvSpPr txBox="1"/>
             <p:nvPr/>
           </p:nvSpPr>
@@ -20604,7 +20717,7 @@
         </p:sp>
         <p:sp>
           <p:nvSpPr>
-            <p:cNvPr id="151" name="Google Shape;151;p17"/>
+            <p:cNvPr id="153" name="Google Shape;153;p17"/>
             <p:cNvSpPr/>
             <p:nvPr/>
           </p:nvSpPr>
@@ -20655,7 +20768,7 @@
         </p:sp>
         <p:sp>
           <p:nvSpPr>
-            <p:cNvPr id="152" name="Google Shape;152;p17"/>
+            <p:cNvPr id="154" name="Google Shape;154;p17"/>
             <p:cNvSpPr txBox="1"/>
             <p:nvPr/>
           </p:nvSpPr>
@@ -20776,107 +20889,6 @@
           </p:txBody>
         </p:sp>
       </p:grpSp>
-      <p:sp>
-        <p:nvSpPr>
-          <p:cNvPr id="153" name="Google Shape;153;p17"/>
-          <p:cNvSpPr txBox="1"/>
-          <p:nvPr/>
-        </p:nvSpPr>
-        <p:spPr>
-          <a:xfrm>
-            <a:off x="809625" y="571500"/>
-            <a:ext cx="11351400" cy="554100"/>
-          </a:xfrm>
-          <a:prstGeom prst="rect">
-            <a:avLst/>
-          </a:prstGeom>
-          <a:noFill/>
-          <a:ln>
-            <a:noFill/>
-          </a:ln>
-        </p:spPr>
-        <p:txBody>
-          <a:bodyPr anchorCtr="0" anchor="t" bIns="0" lIns="0" spcFirstLastPara="1" rIns="0" wrap="square" tIns="0">
-            <a:spAutoFit/>
-          </a:bodyPr>
-          <a:lstStyle/>
-          <a:p>
-            <a:pPr indent="0" lvl="0" marL="0" marR="0" rtl="0" algn="l">
-              <a:spcBef>
-                <a:spcPts val="0"/>
-              </a:spcBef>
-              <a:spcAft>
-                <a:spcPts val="0"/>
-              </a:spcAft>
-              <a:buNone/>
-            </a:pPr>
-            <a:r>
-              <a:rPr b="1" i="0" lang="en-US" sz="3600" u="none" cap="none" strike="noStrike">
-                <a:solidFill>
-                  <a:srgbClr val="F5F5F5"/>
-                </a:solidFill>
-                <a:latin typeface="Urbanist"/>
-                <a:ea typeface="Urbanist"/>
-                <a:cs typeface="Urbanist"/>
-                <a:sym typeface="Urbanist"/>
-              </a:rPr>
-              <a:t>El dataset: 176 días de inteligencia</a:t>
-            </a:r>
-            <a:endParaRPr/>
-          </a:p>
-        </p:txBody>
-      </p:sp>
-      <p:sp>
-        <p:nvSpPr>
-          <p:cNvPr id="154" name="Google Shape;154;p17"/>
-          <p:cNvSpPr/>
-          <p:nvPr/>
-        </p:nvSpPr>
-        <p:spPr>
-          <a:xfrm>
-            <a:off x="571500" y="571500"/>
-            <a:ext cx="57300" cy="552600"/>
-          </a:xfrm>
-          <a:prstGeom prst="rect">
-            <a:avLst/>
-          </a:prstGeom>
-          <a:solidFill>
-            <a:srgbClr val="00C853"/>
-          </a:solidFill>
-          <a:ln>
-            <a:noFill/>
-          </a:ln>
-        </p:spPr>
-        <p:txBody>
-          <a:bodyPr anchorCtr="0" anchor="ctr" bIns="45700" lIns="91425" spcFirstLastPara="1" rIns="91425" wrap="square" tIns="45700">
-            <a:noAutofit/>
-          </a:bodyPr>
-          <a:lstStyle/>
-          <a:p>
-            <a:pPr indent="0" lvl="0" marL="0" marR="0" rtl="0" algn="ctr">
-              <a:spcBef>
-                <a:spcPts val="0"/>
-              </a:spcBef>
-              <a:spcAft>
-                <a:spcPts val="0"/>
-              </a:spcAft>
-              <a:buNone/>
-            </a:pPr>
-            <a:r>
-              <a:t/>
-            </a:r>
-            <a:endParaRPr b="0" i="0" sz="1800" u="none" cap="none" strike="noStrike">
-              <a:solidFill>
-                <a:schemeClr val="dk1"/>
-              </a:solidFill>
-              <a:latin typeface="Calibri"/>
-              <a:ea typeface="Calibri"/>
-              <a:cs typeface="Calibri"/>
-              <a:sym typeface="Calibri"/>
-            </a:endParaRPr>
-          </a:p>
-        </p:txBody>
-      </p:sp>
     </p:spTree>
   </p:cSld>
   <p:clrMapOvr>
@@ -26112,7 +26124,7 @@
                   <a:cs typeface="Urbanist"/>
                   <a:sym typeface="Urbanist"/>
                 </a:rPr>
-                <a:t>IPC: 99,17</a:t>
+                <a:t>IPC: 98,49</a:t>
               </a:r>
               <a:endParaRPr b="1" sz="5400">
                 <a:solidFill>
@@ -26170,7 +26182,31 @@
                   <a:cs typeface="Inter"/>
                   <a:sym typeface="Inter"/>
                 </a:rPr>
-                <a:t>-0,83% desde nov-25</a:t>
+                <a:t>-</a:t>
+              </a:r>
+              <a:r>
+                <a:rPr lang="en-US" sz="1800">
+                  <a:solidFill>
+                    <a:srgbClr val="00C853"/>
+                  </a:solidFill>
+                  <a:latin typeface="Inter"/>
+                  <a:ea typeface="Inter"/>
+                  <a:cs typeface="Inter"/>
+                  <a:sym typeface="Inter"/>
+                </a:rPr>
+                <a:t>1,5</a:t>
+              </a:r>
+              <a:r>
+                <a:rPr b="0" lang="en-US" sz="1800">
+                  <a:solidFill>
+                    <a:srgbClr val="00C853"/>
+                  </a:solidFill>
+                  <a:latin typeface="Inter"/>
+                  <a:ea typeface="Inter"/>
+                  <a:cs typeface="Inter"/>
+                  <a:sym typeface="Inter"/>
+                </a:rPr>
+                <a:t>% desde nov-25</a:t>
               </a:r>
               <a:endParaRPr b="0" sz="1800">
                 <a:solidFill>

</xml_diff>